<commit_message>
P4: showcase custom Claude Code skill ecosystem; re-estimate brute-force traversal as O(N²·k)≈1.9e13 (days–weeks, single core)
Skill names use spectra-* throughout. P2 payoff now contrasts brute-force traversal time vs the signature-gate+cKDTree engine (interactive seconds); removed the misleading ~20s (that is the N=20k containment-suppression substep, kept on P3).

Co-Authored-By: Claude Opus 4.8 (1M context) <noreply@anthropic.com>
</commit_message>
<xml_diff>
--- a/competition/尋形Conform_競賽簡報.pptx
+++ b/competition/尋形Conform_競賽簡報.pptx
@@ -10184,7 +10184,7 @@
         <p:spPr>
           <a:xfrm>
             <a:off x="548640" y="1975104"/>
-            <a:ext cx="3200400" cy="768096"/>
+            <a:ext cx="3200400" cy="713232"/>
           </a:xfrm>
           <a:prstGeom prst="roundRect">
             <a:avLst>
@@ -10239,7 +10239,7 @@
         <p:spPr>
           <a:xfrm>
             <a:off x="658368" y="1975104"/>
-            <a:ext cx="2980944" cy="768096"/>
+            <a:ext cx="2980944" cy="713232"/>
           </a:xfrm>
           <a:prstGeom prst="rect">
             <a:avLst/>
@@ -10281,7 +10281,7 @@
         <p:spPr>
           <a:xfrm>
             <a:off x="4251959" y="1975104"/>
-            <a:ext cx="3200400" cy="768096"/>
+            <a:ext cx="3200400" cy="713232"/>
           </a:xfrm>
           <a:prstGeom prst="roundRect">
             <a:avLst>
@@ -10336,7 +10336,7 @@
         <p:spPr>
           <a:xfrm>
             <a:off x="4361688" y="1975104"/>
-            <a:ext cx="2980944" cy="768096"/>
+            <a:ext cx="2980944" cy="713232"/>
           </a:xfrm>
           <a:prstGeom prst="rect">
             <a:avLst/>
@@ -10378,7 +10378,7 @@
         <p:spPr>
           <a:xfrm>
             <a:off x="7955279" y="1975104"/>
-            <a:ext cx="3200400" cy="768096"/>
+            <a:ext cx="3200400" cy="713232"/>
           </a:xfrm>
           <a:prstGeom prst="roundRect">
             <a:avLst>
@@ -10433,7 +10433,7 @@
         <p:spPr>
           <a:xfrm>
             <a:off x="8065007" y="1975104"/>
-            <a:ext cx="2980944" cy="768096"/>
+            <a:ext cx="2980944" cy="713232"/>
           </a:xfrm>
           <a:prstGeom prst="rect">
             <a:avLst/>
@@ -10474,8 +10474,8 @@
         </p:nvSpPr>
         <p:spPr>
           <a:xfrm>
-            <a:off x="7955279" y="3072384"/>
-            <a:ext cx="3200400" cy="768096"/>
+            <a:off x="7955279" y="2962656"/>
+            <a:ext cx="3200400" cy="713232"/>
           </a:xfrm>
           <a:prstGeom prst="roundRect">
             <a:avLst>
@@ -10529,8 +10529,8 @@
         </p:nvSpPr>
         <p:spPr>
           <a:xfrm>
-            <a:off x="8065007" y="3072384"/>
-            <a:ext cx="2980944" cy="768096"/>
+            <a:off x="8065007" y="2962656"/>
+            <a:ext cx="2980944" cy="713232"/>
           </a:xfrm>
           <a:prstGeom prst="rect">
             <a:avLst/>
@@ -10571,8 +10571,8 @@
         </p:nvSpPr>
         <p:spPr>
           <a:xfrm>
-            <a:off x="4251959" y="3072384"/>
-            <a:ext cx="3200400" cy="768096"/>
+            <a:off x="4251959" y="2962656"/>
+            <a:ext cx="3200400" cy="713232"/>
           </a:xfrm>
           <a:prstGeom prst="roundRect">
             <a:avLst>
@@ -10624,8 +10624,8 @@
         </p:nvSpPr>
         <p:spPr>
           <a:xfrm>
-            <a:off x="4361688" y="3072384"/>
-            <a:ext cx="2980944" cy="768096"/>
+            <a:off x="4361688" y="2962656"/>
+            <a:ext cx="2980944" cy="713232"/>
           </a:xfrm>
           <a:prstGeom prst="rect">
             <a:avLst/>
@@ -10666,8 +10666,8 @@
         </p:nvSpPr>
         <p:spPr>
           <a:xfrm>
-            <a:off x="548640" y="3072384"/>
-            <a:ext cx="3200400" cy="768096"/>
+            <a:off x="548640" y="2962656"/>
+            <a:ext cx="3200400" cy="713232"/>
           </a:xfrm>
           <a:prstGeom prst="roundRect">
             <a:avLst>
@@ -10721,8 +10721,8 @@
         </p:nvSpPr>
         <p:spPr>
           <a:xfrm>
-            <a:off x="658368" y="3072384"/>
-            <a:ext cx="2980944" cy="768096"/>
+            <a:off x="658368" y="2962656"/>
+            <a:ext cx="2980944" cy="713232"/>
           </a:xfrm>
           <a:prstGeom prst="rect">
             <a:avLst/>
@@ -10763,7 +10763,7 @@
         </p:nvSpPr>
         <p:spPr>
           <a:xfrm>
-            <a:off x="3785615" y="2240280"/>
+            <a:off x="3785615" y="2212848"/>
             <a:ext cx="429768" cy="237744"/>
           </a:xfrm>
           <a:prstGeom prst="rightArrow">
@@ -10807,7 +10807,7 @@
         </p:nvSpPr>
         <p:spPr>
           <a:xfrm>
-            <a:off x="7488935" y="2240280"/>
+            <a:off x="7488935" y="2212848"/>
             <a:ext cx="429768" cy="237744"/>
           </a:xfrm>
           <a:prstGeom prst="rightArrow">
@@ -10851,8 +10851,8 @@
         </p:nvSpPr>
         <p:spPr>
           <a:xfrm>
-            <a:off x="9436607" y="2761488"/>
-            <a:ext cx="237744" cy="292608"/>
+            <a:off x="9436607" y="2706624"/>
+            <a:ext cx="237744" cy="237744"/>
           </a:xfrm>
           <a:prstGeom prst="downArrow">
             <a:avLst/>
@@ -10895,7 +10895,7 @@
         </p:nvSpPr>
         <p:spPr>
           <a:xfrm>
-            <a:off x="7488935" y="3337560"/>
+            <a:off x="7488935" y="3200400"/>
             <a:ext cx="429768" cy="237744"/>
           </a:xfrm>
           <a:prstGeom prst="leftArrow">
@@ -10939,7 +10939,7 @@
         </p:nvSpPr>
         <p:spPr>
           <a:xfrm>
-            <a:off x="3785615" y="3337560"/>
+            <a:off x="3785615" y="3200400"/>
             <a:ext cx="429768" cy="237744"/>
           </a:xfrm>
           <a:prstGeom prst="leftArrow">
@@ -10983,8 +10983,8 @@
         </p:nvSpPr>
         <p:spPr>
           <a:xfrm>
-            <a:off x="2029968" y="2761488"/>
-            <a:ext cx="237744" cy="292608"/>
+            <a:off x="2029968" y="2706624"/>
+            <a:ext cx="237744" cy="237744"/>
           </a:xfrm>
           <a:prstGeom prst="upArrow">
             <a:avLst/>
@@ -11027,8 +11027,8 @@
         </p:nvSpPr>
         <p:spPr>
           <a:xfrm>
-            <a:off x="548640" y="4023360"/>
-            <a:ext cx="3017520" cy="420624"/>
+            <a:off x="548640" y="3803904"/>
+            <a:ext cx="3611880" cy="384048"/>
           </a:xfrm>
           <a:prstGeom prst="roundRect">
             <a:avLst>
@@ -11073,8 +11073,8 @@
         </p:nvSpPr>
         <p:spPr>
           <a:xfrm>
-            <a:off x="594360" y="4023360"/>
-            <a:ext cx="2926079" cy="420624"/>
+            <a:off x="594360" y="3803904"/>
+            <a:ext cx="3520440" cy="384048"/>
           </a:xfrm>
           <a:prstGeom prst="rect">
             <a:avLst/>
@@ -11110,91 +11110,8 @@
         </p:nvSpPr>
         <p:spPr>
           <a:xfrm>
-            <a:off x="3703320" y="4023360"/>
-            <a:ext cx="2331720" cy="420624"/>
-          </a:xfrm>
-          <a:prstGeom prst="roundRect">
-            <a:avLst>
-              <a:gd name="adj" fmla="val 50000"/>
-            </a:avLst>
-          </a:prstGeom>
-          <a:solidFill>
-            <a:srgbClr val="0E7490"/>
-          </a:solidFill>
-          <a:ln>
-            <a:noFill/>
-          </a:ln>
-          <a:effectLst/>
-        </p:spPr>
-        <p:style>
-          <a:lnRef idx="1">
-            <a:schemeClr val="accent1"/>
-          </a:lnRef>
-          <a:fillRef idx="3">
-            <a:schemeClr val="accent1"/>
-          </a:fillRef>
-          <a:effectRef idx="2">
-            <a:schemeClr val="accent1"/>
-          </a:effectRef>
-          <a:fontRef idx="minor">
-            <a:schemeClr val="lt1"/>
-          </a:fontRef>
-        </p:style>
-        <p:txBody>
-          <a:bodyPr rtlCol="0" anchor="ctr"/>
-          <a:lstStyle/>
-          <a:p>
-            <a:pPr algn="ctr"/>
-          </a:p>
-        </p:txBody>
-      </p:sp>
-      <p:sp>
-        <p:nvSpPr>
-          <p:cNvPr id="36" name="TextBox 35"/>
-          <p:cNvSpPr txBox="1"/>
-          <p:nvPr/>
-        </p:nvSpPr>
-        <p:spPr>
-          <a:xfrm>
-            <a:off x="3749039" y="4023360"/>
-            <a:ext cx="2240279" cy="420624"/>
-          </a:xfrm>
-          <a:prstGeom prst="rect">
-            <a:avLst/>
-          </a:prstGeom>
-          <a:noFill/>
-        </p:spPr>
-        <p:txBody>
-          <a:bodyPr wrap="square" anchor="ctr" lIns="0" rIns="0" tIns="0" bIns="0">
-            <a:spAutoFit/>
-          </a:bodyPr>
-          <a:lstStyle/>
-          <a:p>
-            <a:pPr algn="ctr"/>
-            <a:r>
-              <a:rPr sz="1050" b="1" i="0">
-                <a:solidFill>
-                  <a:srgbClr val="FFFFFF"/>
-                </a:solidFill>
-                <a:latin typeface="PingFang TC"/>
-                <a:ea typeface="PingFang TC"/>
-                <a:cs typeface="PingFang TC"/>
-              </a:rPr>
-              <a:t>Skills：spectra 規格流 · add-rule</a:t>
-            </a:r>
-          </a:p>
-        </p:txBody>
-      </p:sp>
-      <p:sp>
-        <p:nvSpPr>
-          <p:cNvPr id="37" name="Rounded Rectangle 36"/>
-          <p:cNvSpPr/>
-          <p:nvPr/>
-        </p:nvSpPr>
-        <p:spPr>
-          <a:xfrm>
-            <a:off x="6172200" y="4023360"/>
-            <a:ext cx="2788920" cy="420624"/>
+            <a:off x="4343400" y="3803904"/>
+            <a:ext cx="3566160" cy="384048"/>
           </a:xfrm>
           <a:prstGeom prst="roundRect">
             <a:avLst>
@@ -11233,14 +11150,14 @@
       </p:sp>
       <p:sp>
         <p:nvSpPr>
-          <p:cNvPr id="38" name="TextBox 37"/>
+          <p:cNvPr id="36" name="TextBox 35"/>
           <p:cNvSpPr txBox="1"/>
           <p:nvPr/>
         </p:nvSpPr>
         <p:spPr>
           <a:xfrm>
-            <a:off x="6217920" y="4023360"/>
-            <a:ext cx="2697479" cy="420624"/>
+            <a:off x="4389120" y="3803904"/>
+            <a:ext cx="3474720" cy="384048"/>
           </a:xfrm>
           <a:prstGeom prst="rect">
             <a:avLst/>
@@ -11270,14 +11187,14 @@
       </p:sp>
       <p:sp>
         <p:nvSpPr>
-          <p:cNvPr id="39" name="Rounded Rectangle 38"/>
+          <p:cNvPr id="37" name="Rounded Rectangle 36"/>
           <p:cNvSpPr/>
           <p:nvPr/>
         </p:nvSpPr>
         <p:spPr>
           <a:xfrm>
-            <a:off x="9098280" y="4023360"/>
-            <a:ext cx="2542032" cy="420624"/>
+            <a:off x="8092440" y="3803904"/>
+            <a:ext cx="3547872" cy="384048"/>
           </a:xfrm>
           <a:prstGeom prst="roundRect">
             <a:avLst>
@@ -11316,14 +11233,14 @@
       </p:sp>
       <p:sp>
         <p:nvSpPr>
-          <p:cNvPr id="40" name="TextBox 39"/>
+          <p:cNvPr id="38" name="TextBox 37"/>
           <p:cNvSpPr txBox="1"/>
           <p:nvPr/>
         </p:nvSpPr>
         <p:spPr>
           <a:xfrm>
-            <a:off x="9144000" y="4023360"/>
-            <a:ext cx="2450591" cy="420624"/>
+            <a:off x="8138160" y="3803904"/>
+            <a:ext cx="3456432" cy="384048"/>
           </a:xfrm>
           <a:prstGeom prst="rect">
             <a:avLst/>
@@ -11353,14 +11270,135 @@
       </p:sp>
       <p:sp>
         <p:nvSpPr>
+          <p:cNvPr id="39" name="Rounded Rectangle 38"/>
+          <p:cNvSpPr/>
+          <p:nvPr/>
+        </p:nvSpPr>
+        <p:spPr>
+          <a:xfrm>
+            <a:off x="548640" y="4279392"/>
+            <a:ext cx="11091672" cy="566928"/>
+          </a:xfrm>
+          <a:prstGeom prst="roundRect">
+            <a:avLst>
+              <a:gd name="adj" fmla="val 10000"/>
+            </a:avLst>
+          </a:prstGeom>
+          <a:solidFill>
+            <a:srgbClr val="EAF0FA"/>
+          </a:solidFill>
+          <a:ln w="12700">
+            <a:solidFill>
+              <a:srgbClr val="DCE3F0"/>
+            </a:solidFill>
+          </a:ln>
+          <a:effectLst/>
+          <a:effectLst>
+            <a:outerShdw blurRad="55000" dist="20000" dir="5400000" rotWithShape="0">
+              <a:srgbClr val="2A3A55">
+                <a:alpha val="26000"/>
+              </a:srgbClr>
+            </a:outerShdw>
+          </a:effectLst>
+        </p:spPr>
+        <p:style>
+          <a:lnRef idx="1">
+            <a:schemeClr val="accent1"/>
+          </a:lnRef>
+          <a:fillRef idx="3">
+            <a:schemeClr val="accent1"/>
+          </a:fillRef>
+          <a:effectRef idx="2">
+            <a:schemeClr val="accent1"/>
+          </a:effectRef>
+          <a:fontRef idx="minor">
+            <a:schemeClr val="lt1"/>
+          </a:fontRef>
+        </p:style>
+        <p:txBody>
+          <a:bodyPr rtlCol="0" anchor="ctr"/>
+          <a:lstStyle/>
+          <a:p>
+            <a:pPr algn="ctr"/>
+          </a:p>
+        </p:txBody>
+      </p:sp>
+      <p:sp>
+        <p:nvSpPr>
+          <p:cNvPr id="40" name="TextBox 39"/>
+          <p:cNvSpPr txBox="1"/>
+          <p:nvPr/>
+        </p:nvSpPr>
+        <p:spPr>
+          <a:xfrm>
+            <a:off x="777240" y="4279392"/>
+            <a:ext cx="10652760" cy="566928"/>
+          </a:xfrm>
+          <a:prstGeom prst="rect">
+            <a:avLst/>
+          </a:prstGeom>
+          <a:noFill/>
+        </p:spPr>
+        <p:txBody>
+          <a:bodyPr wrap="square" anchor="ctr" lIns="0" rIns="0" tIns="0" bIns="0">
+            <a:spAutoFit/>
+          </a:bodyPr>
+          <a:lstStyle/>
+          <a:p>
+            <a:pPr algn="l">
+              <a:spcAft>
+                <a:spcPts val="200"/>
+              </a:spcAft>
+            </a:pPr>
+            <a:r>
+              <a:rPr sz="1100" b="1" i="0">
+                <a:solidFill>
+                  <a:srgbClr val="0E7490"/>
+                </a:solidFill>
+                <a:latin typeface="PingFang TC"/>
+                <a:ea typeface="PingFang TC"/>
+                <a:cs typeface="PingFang TC"/>
+              </a:rPr>
+              <a:t>Skills｜自建技能生態　</a:t>
+            </a:r>
+            <a:r>
+              <a:rPr sz="1000" b="0" i="0">
+                <a:solidFill>
+                  <a:srgbClr val="1F2D45"/>
+                </a:solidFill>
+                <a:latin typeface="PingFang TC"/>
+                <a:ea typeface="PingFang TC"/>
+                <a:cs typeface="PingFang TC"/>
+              </a:rPr>
+              <a:t>規格流 spectra-* ×12（propose→apply→archive→verify…）· 測試 tdd · 審查 grill-me / grill-with-docs / diagnose / triage</a:t>
+            </a:r>
+          </a:p>
+          <a:p>
+            <a:pPr algn="l"/>
+            <a:r>
+              <a:rPr sz="1000" b="0" i="0">
+                <a:solidFill>
+                  <a:srgbClr val="5C6B8A"/>
+                </a:solidFill>
+                <a:latin typeface="PingFang TC"/>
+                <a:ea typeface="PingFang TC"/>
+                <a:cs typeface="PingFang TC"/>
+              </a:rPr>
+              <a:t>規劃 to-prd / to-issues · 領域 add-rule · 雛型 prototype · 架構 improve-codebase-architecture · zoom-out · write-a-skill · caveman</a:t>
+            </a:r>
+          </a:p>
+        </p:txBody>
+      </p:sp>
+      <p:sp>
+        <p:nvSpPr>
           <p:cNvPr id="41" name="Rounded Rectangle 40"/>
           <p:cNvSpPr/>
           <p:nvPr/>
         </p:nvSpPr>
         <p:spPr>
           <a:xfrm>
-            <a:off x="548640" y="4590288"/>
-            <a:ext cx="11091672" cy="1335024"/>
+            <a:off x="548640" y="4937759"/>
+            <a:ext cx="11091672" cy="1225296"/>
           </a:xfrm>
           <a:prstGeom prst="roundRect">
             <a:avLst>
@@ -11414,7 +11452,7 @@
         </p:nvSpPr>
         <p:spPr>
           <a:xfrm>
-            <a:off x="777240" y="4700016"/>
+            <a:off x="777240" y="5029199"/>
             <a:ext cx="10607040" cy="365760"/>
           </a:xfrm>
           <a:prstGeom prst="rect">
@@ -11430,7 +11468,7 @@
           <a:p>
             <a:pPr algn="l"/>
             <a:r>
-              <a:rPr sz="1350" b="1" i="0">
+              <a:rPr sz="1300" b="1" i="0">
                 <a:solidFill>
                   <a:srgbClr val="162039"/>
                 </a:solidFill>
@@ -11451,7 +11489,7 @@
         </p:nvSpPr>
         <p:spPr>
           <a:xfrm>
-            <a:off x="777240" y="5102352"/>
+            <a:off x="777240" y="5413248"/>
             <a:ext cx="1417320" cy="182880"/>
           </a:xfrm>
           <a:prstGeom prst="roundRect">
@@ -11497,7 +11535,7 @@
         </p:nvSpPr>
         <p:spPr>
           <a:xfrm>
-            <a:off x="822960" y="5102352"/>
+            <a:off x="822960" y="5413248"/>
             <a:ext cx="1325880" cy="182880"/>
           </a:xfrm>
           <a:prstGeom prst="rect">
@@ -11534,7 +11572,7 @@
         </p:nvSpPr>
         <p:spPr>
           <a:xfrm>
-            <a:off x="2286000" y="5084064"/>
+            <a:off x="2286000" y="5394960"/>
             <a:ext cx="9235440" cy="237744"/>
           </a:xfrm>
           <a:prstGeom prst="rect">
@@ -11571,7 +11609,7 @@
         </p:nvSpPr>
         <p:spPr>
           <a:xfrm>
-            <a:off x="777240" y="5308092"/>
+            <a:off x="777240" y="5600700"/>
             <a:ext cx="1417320" cy="182880"/>
           </a:xfrm>
           <a:prstGeom prst="roundRect">
@@ -11617,7 +11655,7 @@
         </p:nvSpPr>
         <p:spPr>
           <a:xfrm>
-            <a:off x="822960" y="5308092"/>
+            <a:off x="822960" y="5600700"/>
             <a:ext cx="1325880" cy="182880"/>
           </a:xfrm>
           <a:prstGeom prst="rect">
@@ -11654,7 +11692,7 @@
         </p:nvSpPr>
         <p:spPr>
           <a:xfrm>
-            <a:off x="2286000" y="5289804"/>
+            <a:off x="2286000" y="5582412"/>
             <a:ext cx="9235440" cy="237744"/>
           </a:xfrm>
           <a:prstGeom prst="rect">
@@ -11691,7 +11729,7 @@
         </p:nvSpPr>
         <p:spPr>
           <a:xfrm>
-            <a:off x="777240" y="5513832"/>
+            <a:off x="777240" y="5788152"/>
             <a:ext cx="1417320" cy="182880"/>
           </a:xfrm>
           <a:prstGeom prst="roundRect">
@@ -11737,7 +11775,7 @@
         </p:nvSpPr>
         <p:spPr>
           <a:xfrm>
-            <a:off x="822960" y="5513832"/>
+            <a:off x="822960" y="5788152"/>
             <a:ext cx="1325880" cy="182880"/>
           </a:xfrm>
           <a:prstGeom prst="rect">
@@ -11774,7 +11812,7 @@
         </p:nvSpPr>
         <p:spPr>
           <a:xfrm>
-            <a:off x="2286000" y="5495544"/>
+            <a:off x="2286000" y="5769864"/>
             <a:ext cx="9235440" cy="237744"/>
           </a:xfrm>
           <a:prstGeom prst="rect">
@@ -11811,7 +11849,7 @@
         </p:nvSpPr>
         <p:spPr>
           <a:xfrm>
-            <a:off x="777240" y="5719572"/>
+            <a:off x="777240" y="5975604"/>
             <a:ext cx="1417320" cy="182880"/>
           </a:xfrm>
           <a:prstGeom prst="roundRect">
@@ -11857,7 +11895,7 @@
         </p:nvSpPr>
         <p:spPr>
           <a:xfrm>
-            <a:off x="822960" y="5719572"/>
+            <a:off x="822960" y="5975604"/>
             <a:ext cx="1325880" cy="182880"/>
           </a:xfrm>
           <a:prstGeom prst="rect">
@@ -11894,7 +11932,7 @@
         </p:nvSpPr>
         <p:spPr>
           <a:xfrm>
-            <a:off x="2286000" y="5701284"/>
+            <a:off x="2286000" y="5957316"/>
             <a:ext cx="9235440" cy="237744"/>
           </a:xfrm>
           <a:prstGeom prst="rect">
@@ -11931,7 +11969,7 @@
         </p:nvSpPr>
         <p:spPr>
           <a:xfrm>
-            <a:off x="548640" y="6016752"/>
+            <a:off x="548640" y="6236207"/>
             <a:ext cx="11091672" cy="310896"/>
           </a:xfrm>
           <a:prstGeom prst="rect">

</xml_diff>

<commit_message>
deck: enforce 12pt minimum font size globally
MIN_PT floor in _setfont guarantees no run renders below 12pt;
shorten skills band / astronomy footnote and widen BACKUP table
rows so bumped text still fits.

Co-Authored-By: Claude Fable 5 <noreply@anthropic.com>
</commit_message>
<xml_diff>
--- a/competition/尋形Conform_競賽簡報.pptx
+++ b/competition/尋形Conform_競賽簡報.pptx
@@ -601,7 +601,7 @@
           </a:p>
           <a:p>
             <a:r>
-              <a:t>字級：理由欄為求容納 7 列降到 10.5pt——backup 參考用，不進主線。</a:t>
+              <a:t>字級：全簡報由 _setfont 強制 ≥12pt（MIN_PT），此表理由欄 12pt 兩行內收納。</a:t>
             </a:r>
           </a:p>
           <a:p>
@@ -4929,7 +4929,7 @@
           <a:p>
             <a:pPr algn="ctr"/>
             <a:r>
-              <a:rPr sz="1050" b="0" i="0">
+              <a:rPr sz="1200" b="0" i="0">
                 <a:solidFill>
                   <a:srgbClr val="90A0C0"/>
                 </a:solidFill>
@@ -5056,7 +5056,7 @@
           <a:p>
             <a:pPr algn="ctr"/>
             <a:r>
-              <a:rPr sz="1050" b="0" i="0">
+              <a:rPr sz="1200" b="0" i="0">
                 <a:solidFill>
                   <a:srgbClr val="90A0C0"/>
                 </a:solidFill>
@@ -5183,7 +5183,7 @@
           <a:p>
             <a:pPr algn="ctr"/>
             <a:r>
-              <a:rPr sz="1050" b="0" i="0">
+              <a:rPr sz="1200" b="0" i="0">
                 <a:solidFill>
                   <a:srgbClr val="90A0C0"/>
                 </a:solidFill>
@@ -5220,7 +5220,7 @@
           <a:p>
             <a:pPr algn="r"/>
             <a:r>
-              <a:rPr sz="1100" b="1" i="0">
+              <a:rPr sz="1200" b="1" i="0">
                 <a:solidFill>
                   <a:srgbClr val="22D3EE"/>
                 </a:solidFill>
@@ -5383,7 +5383,7 @@
               <a:t>附錄</a:t>
             </a:r>
             <a:r>
-              <a:rPr sz="1100" b="1" i="0">
+              <a:rPr sz="1200" b="1" i="0">
                 <a:solidFill>
                   <a:srgbClr val="FFFFFF"/>
                 </a:solidFill>
@@ -5753,7 +5753,7 @@
           <a:p>
             <a:pPr algn="r"/>
             <a:r>
-              <a:rPr sz="1100" b="1" i="0">
+              <a:rPr sz="1200" b="1" i="0">
                 <a:solidFill>
                   <a:srgbClr val="5C6B8A"/>
                 </a:solidFill>
@@ -6050,7 +6050,7 @@
         <p:spPr>
           <a:xfrm>
             <a:off x="457200" y="2404872"/>
-            <a:ext cx="11274552" cy="530352"/>
+            <a:ext cx="11274552" cy="548640"/>
           </a:xfrm>
           <a:prstGeom prst="rect">
             <a:avLst/>
@@ -6096,7 +6096,7 @@
         <p:spPr>
           <a:xfrm>
             <a:off x="566928" y="2404872"/>
-            <a:ext cx="1645920" cy="530352"/>
+            <a:ext cx="1645920" cy="548640"/>
           </a:xfrm>
           <a:prstGeom prst="rect">
             <a:avLst/>
@@ -6115,7 +6115,7 @@
               </a:lnSpc>
             </a:pPr>
             <a:r>
-              <a:rPr sz="1150" b="1" i="0">
+              <a:rPr sz="1200" b="1" i="0">
                 <a:solidFill>
                   <a:srgbClr val="162039"/>
                 </a:solidFill>
@@ -6137,7 +6137,7 @@
         <p:spPr>
           <a:xfrm>
             <a:off x="2395728" y="2404872"/>
-            <a:ext cx="1828800" cy="530352"/>
+            <a:ext cx="1828800" cy="548640"/>
           </a:xfrm>
           <a:prstGeom prst="rect">
             <a:avLst/>
@@ -6156,7 +6156,7 @@
               </a:lnSpc>
             </a:pPr>
             <a:r>
-              <a:rPr sz="1050" b="0" i="0">
+              <a:rPr sz="1200" b="0" i="0">
                 <a:solidFill>
                   <a:srgbClr val="1F2D45"/>
                 </a:solidFill>
@@ -6178,7 +6178,7 @@
         <p:spPr>
           <a:xfrm>
             <a:off x="4389120" y="2404872"/>
-            <a:ext cx="1170431" cy="530352"/>
+            <a:ext cx="1170431" cy="548640"/>
           </a:xfrm>
           <a:prstGeom prst="rect">
             <a:avLst/>
@@ -6197,7 +6197,7 @@
               </a:lnSpc>
             </a:pPr>
             <a:r>
-              <a:rPr sz="1100" b="1" i="0">
+              <a:rPr sz="1200" b="1" i="0">
                 <a:solidFill>
                   <a:srgbClr val="F43F5E"/>
                 </a:solidFill>
@@ -6219,7 +6219,7 @@
         <p:spPr>
           <a:xfrm>
             <a:off x="5705856" y="2404872"/>
-            <a:ext cx="3776471" cy="530352"/>
+            <a:ext cx="3776471" cy="548640"/>
           </a:xfrm>
           <a:prstGeom prst="rect">
             <a:avLst/>
@@ -6238,7 +6238,7 @@
               </a:lnSpc>
             </a:pPr>
             <a:r>
-              <a:rPr sz="1050" b="0" i="0">
+              <a:rPr sz="1200" b="0" i="0">
                 <a:solidFill>
                   <a:srgbClr val="1F2D45"/>
                 </a:solidFill>
@@ -6260,7 +6260,7 @@
         <p:spPr>
           <a:xfrm>
             <a:off x="9665207" y="2404872"/>
-            <a:ext cx="1993392" cy="530352"/>
+            <a:ext cx="1993392" cy="548640"/>
           </a:xfrm>
           <a:prstGeom prst="rect">
             <a:avLst/>
@@ -6279,7 +6279,7 @@
               </a:lnSpc>
             </a:pPr>
             <a:r>
-              <a:rPr sz="1050" b="1" i="0">
+              <a:rPr sz="1200" b="1" i="0">
                 <a:solidFill>
                   <a:srgbClr val="0E7490"/>
                 </a:solidFill>
@@ -6300,8 +6300,8 @@
         </p:nvSpPr>
         <p:spPr>
           <a:xfrm>
-            <a:off x="457200" y="2935224"/>
-            <a:ext cx="11274552" cy="530352"/>
+            <a:off x="457200" y="2953512"/>
+            <a:ext cx="11274552" cy="548640"/>
           </a:xfrm>
           <a:prstGeom prst="rect">
             <a:avLst/>
@@ -6346,8 +6346,8 @@
         </p:nvSpPr>
         <p:spPr>
           <a:xfrm>
-            <a:off x="566928" y="2935224"/>
-            <a:ext cx="1645920" cy="530352"/>
+            <a:off x="566928" y="2953512"/>
+            <a:ext cx="1645920" cy="548640"/>
           </a:xfrm>
           <a:prstGeom prst="rect">
             <a:avLst/>
@@ -6366,7 +6366,7 @@
               </a:lnSpc>
             </a:pPr>
             <a:r>
-              <a:rPr sz="1150" b="1" i="0">
+              <a:rPr sz="1200" b="1" i="0">
                 <a:solidFill>
                   <a:srgbClr val="162039"/>
                 </a:solidFill>
@@ -6387,8 +6387,8 @@
         </p:nvSpPr>
         <p:spPr>
           <a:xfrm>
-            <a:off x="2395728" y="2935224"/>
-            <a:ext cx="1828800" cy="530352"/>
+            <a:off x="2395728" y="2953512"/>
+            <a:ext cx="1828800" cy="548640"/>
           </a:xfrm>
           <a:prstGeom prst="rect">
             <a:avLst/>
@@ -6407,7 +6407,7 @@
               </a:lnSpc>
             </a:pPr>
             <a:r>
-              <a:rPr sz="1050" b="0" i="0">
+              <a:rPr sz="1200" b="0" i="0">
                 <a:solidFill>
                   <a:srgbClr val="1F2D45"/>
                 </a:solidFill>
@@ -6428,8 +6428,8 @@
         </p:nvSpPr>
         <p:spPr>
           <a:xfrm>
-            <a:off x="4389120" y="2935224"/>
-            <a:ext cx="1170431" cy="530352"/>
+            <a:off x="4389120" y="2953512"/>
+            <a:ext cx="1170431" cy="548640"/>
           </a:xfrm>
           <a:prstGeom prst="rect">
             <a:avLst/>
@@ -6448,7 +6448,7 @@
               </a:lnSpc>
             </a:pPr>
             <a:r>
-              <a:rPr sz="1100" b="1" i="0">
+              <a:rPr sz="1200" b="1" i="0">
                 <a:solidFill>
                   <a:srgbClr val="2A8F5F"/>
                 </a:solidFill>
@@ -6469,8 +6469,8 @@
         </p:nvSpPr>
         <p:spPr>
           <a:xfrm>
-            <a:off x="5705856" y="2935224"/>
-            <a:ext cx="3776471" cy="530352"/>
+            <a:off x="5705856" y="2953512"/>
+            <a:ext cx="3776471" cy="548640"/>
           </a:xfrm>
           <a:prstGeom prst="rect">
             <a:avLst/>
@@ -6489,7 +6489,7 @@
               </a:lnSpc>
             </a:pPr>
             <a:r>
-              <a:rPr sz="1050" b="0" i="0">
+              <a:rPr sz="1200" b="0" i="0">
                 <a:solidFill>
                   <a:srgbClr val="1F2D45"/>
                 </a:solidFill>
@@ -6510,8 +6510,8 @@
         </p:nvSpPr>
         <p:spPr>
           <a:xfrm>
-            <a:off x="9665207" y="2935224"/>
-            <a:ext cx="1993392" cy="530352"/>
+            <a:off x="9665207" y="2953512"/>
+            <a:ext cx="1993392" cy="548640"/>
           </a:xfrm>
           <a:prstGeom prst="rect">
             <a:avLst/>
@@ -6530,7 +6530,7 @@
               </a:lnSpc>
             </a:pPr>
             <a:r>
-              <a:rPr sz="1050" b="1" i="0">
+              <a:rPr sz="1200" b="1" i="0">
                 <a:solidFill>
                   <a:srgbClr val="0E7490"/>
                 </a:solidFill>
@@ -6551,8 +6551,8 @@
         </p:nvSpPr>
         <p:spPr>
           <a:xfrm>
-            <a:off x="457200" y="3465576"/>
-            <a:ext cx="11274552" cy="530352"/>
+            <a:off x="457200" y="3502152"/>
+            <a:ext cx="11274552" cy="548640"/>
           </a:xfrm>
           <a:prstGeom prst="rect">
             <a:avLst/>
@@ -6597,8 +6597,8 @@
         </p:nvSpPr>
         <p:spPr>
           <a:xfrm>
-            <a:off x="566928" y="3465576"/>
-            <a:ext cx="1645920" cy="530352"/>
+            <a:off x="566928" y="3502152"/>
+            <a:ext cx="1645920" cy="548640"/>
           </a:xfrm>
           <a:prstGeom prst="rect">
             <a:avLst/>
@@ -6617,7 +6617,7 @@
               </a:lnSpc>
             </a:pPr>
             <a:r>
-              <a:rPr sz="1150" b="1" i="0">
+              <a:rPr sz="1200" b="1" i="0">
                 <a:solidFill>
                   <a:srgbClr val="162039"/>
                 </a:solidFill>
@@ -6638,8 +6638,8 @@
         </p:nvSpPr>
         <p:spPr>
           <a:xfrm>
-            <a:off x="2395728" y="3465576"/>
-            <a:ext cx="1828800" cy="530352"/>
+            <a:off x="2395728" y="3502152"/>
+            <a:ext cx="1828800" cy="548640"/>
           </a:xfrm>
           <a:prstGeom prst="rect">
             <a:avLst/>
@@ -6658,7 +6658,7 @@
               </a:lnSpc>
             </a:pPr>
             <a:r>
-              <a:rPr sz="1050" b="0" i="0">
+              <a:rPr sz="1200" b="0" i="0">
                 <a:solidFill>
                   <a:srgbClr val="1F2D45"/>
                 </a:solidFill>
@@ -6679,8 +6679,8 @@
         </p:nvSpPr>
         <p:spPr>
           <a:xfrm>
-            <a:off x="4389120" y="3465576"/>
-            <a:ext cx="1170431" cy="530352"/>
+            <a:off x="4389120" y="3502152"/>
+            <a:ext cx="1170431" cy="548640"/>
           </a:xfrm>
           <a:prstGeom prst="rect">
             <a:avLst/>
@@ -6699,7 +6699,7 @@
               </a:lnSpc>
             </a:pPr>
             <a:r>
-              <a:rPr sz="1100" b="1" i="0">
+              <a:rPr sz="1200" b="1" i="0">
                 <a:solidFill>
                   <a:srgbClr val="F59E0B"/>
                 </a:solidFill>
@@ -6720,8 +6720,8 @@
         </p:nvSpPr>
         <p:spPr>
           <a:xfrm>
-            <a:off x="5705856" y="3465576"/>
-            <a:ext cx="3776471" cy="530352"/>
+            <a:off x="5705856" y="3502152"/>
+            <a:ext cx="3776471" cy="548640"/>
           </a:xfrm>
           <a:prstGeom prst="rect">
             <a:avLst/>
@@ -6740,7 +6740,7 @@
               </a:lnSpc>
             </a:pPr>
             <a:r>
-              <a:rPr sz="1050" b="0" i="0">
+              <a:rPr sz="1200" b="0" i="0">
                 <a:solidFill>
                   <a:srgbClr val="1F2D45"/>
                 </a:solidFill>
@@ -6761,8 +6761,8 @@
         </p:nvSpPr>
         <p:spPr>
           <a:xfrm>
-            <a:off x="9665207" y="3465576"/>
-            <a:ext cx="1993392" cy="530352"/>
+            <a:off x="9665207" y="3502152"/>
+            <a:ext cx="1993392" cy="548640"/>
           </a:xfrm>
           <a:prstGeom prst="rect">
             <a:avLst/>
@@ -6781,7 +6781,7 @@
               </a:lnSpc>
             </a:pPr>
             <a:r>
-              <a:rPr sz="1050" b="1" i="0">
+              <a:rPr sz="1200" b="1" i="0">
                 <a:solidFill>
                   <a:srgbClr val="0E7490"/>
                 </a:solidFill>
@@ -6802,8 +6802,8 @@
         </p:nvSpPr>
         <p:spPr>
           <a:xfrm>
-            <a:off x="457200" y="3995928"/>
-            <a:ext cx="11274552" cy="530352"/>
+            <a:off x="457200" y="4050791"/>
+            <a:ext cx="11274552" cy="548640"/>
           </a:xfrm>
           <a:prstGeom prst="rect">
             <a:avLst/>
@@ -6848,8 +6848,8 @@
         </p:nvSpPr>
         <p:spPr>
           <a:xfrm>
-            <a:off x="566928" y="3995928"/>
-            <a:ext cx="1645920" cy="530352"/>
+            <a:off x="566928" y="4050791"/>
+            <a:ext cx="1645920" cy="548640"/>
           </a:xfrm>
           <a:prstGeom prst="rect">
             <a:avLst/>
@@ -6868,7 +6868,7 @@
               </a:lnSpc>
             </a:pPr>
             <a:r>
-              <a:rPr sz="1150" b="1" i="0">
+              <a:rPr sz="1200" b="1" i="0">
                 <a:solidFill>
                   <a:srgbClr val="162039"/>
                 </a:solidFill>
@@ -6889,8 +6889,8 @@
         </p:nvSpPr>
         <p:spPr>
           <a:xfrm>
-            <a:off x="2395728" y="3995928"/>
-            <a:ext cx="1828800" cy="530352"/>
+            <a:off x="2395728" y="4050791"/>
+            <a:ext cx="1828800" cy="548640"/>
           </a:xfrm>
           <a:prstGeom prst="rect">
             <a:avLst/>
@@ -6909,7 +6909,7 @@
               </a:lnSpc>
             </a:pPr>
             <a:r>
-              <a:rPr sz="1050" b="0" i="0">
+              <a:rPr sz="1200" b="0" i="0">
                 <a:solidFill>
                   <a:srgbClr val="1F2D45"/>
                 </a:solidFill>
@@ -6930,8 +6930,8 @@
         </p:nvSpPr>
         <p:spPr>
           <a:xfrm>
-            <a:off x="4389120" y="3995928"/>
-            <a:ext cx="1170431" cy="530352"/>
+            <a:off x="4389120" y="4050791"/>
+            <a:ext cx="1170431" cy="548640"/>
           </a:xfrm>
           <a:prstGeom prst="rect">
             <a:avLst/>
@@ -6950,7 +6950,7 @@
               </a:lnSpc>
             </a:pPr>
             <a:r>
-              <a:rPr sz="1100" b="1" i="0">
+              <a:rPr sz="1200" b="1" i="0">
                 <a:solidFill>
                   <a:srgbClr val="F59E0B"/>
                 </a:solidFill>
@@ -6971,8 +6971,8 @@
         </p:nvSpPr>
         <p:spPr>
           <a:xfrm>
-            <a:off x="5705856" y="3995928"/>
-            <a:ext cx="3776471" cy="530352"/>
+            <a:off x="5705856" y="4050791"/>
+            <a:ext cx="3776471" cy="548640"/>
           </a:xfrm>
           <a:prstGeom prst="rect">
             <a:avLst/>
@@ -6991,7 +6991,7 @@
               </a:lnSpc>
             </a:pPr>
             <a:r>
-              <a:rPr sz="1050" b="0" i="0">
+              <a:rPr sz="1200" b="0" i="0">
                 <a:solidFill>
                   <a:srgbClr val="1F2D45"/>
                 </a:solidFill>
@@ -7012,8 +7012,8 @@
         </p:nvSpPr>
         <p:spPr>
           <a:xfrm>
-            <a:off x="9665207" y="3995928"/>
-            <a:ext cx="1993392" cy="530352"/>
+            <a:off x="9665207" y="4050791"/>
+            <a:ext cx="1993392" cy="548640"/>
           </a:xfrm>
           <a:prstGeom prst="rect">
             <a:avLst/>
@@ -7032,7 +7032,7 @@
               </a:lnSpc>
             </a:pPr>
             <a:r>
-              <a:rPr sz="1050" b="1" i="0">
+              <a:rPr sz="1200" b="1" i="0">
                 <a:solidFill>
                   <a:srgbClr val="0E7490"/>
                 </a:solidFill>
@@ -7053,8 +7053,8 @@
         </p:nvSpPr>
         <p:spPr>
           <a:xfrm>
-            <a:off x="457200" y="4526280"/>
-            <a:ext cx="11274552" cy="530352"/>
+            <a:off x="457200" y="4599431"/>
+            <a:ext cx="11274552" cy="548640"/>
           </a:xfrm>
           <a:prstGeom prst="rect">
             <a:avLst/>
@@ -7099,8 +7099,8 @@
         </p:nvSpPr>
         <p:spPr>
           <a:xfrm>
-            <a:off x="566928" y="4526280"/>
-            <a:ext cx="1645920" cy="530352"/>
+            <a:off x="566928" y="4599431"/>
+            <a:ext cx="1645920" cy="548640"/>
           </a:xfrm>
           <a:prstGeom prst="rect">
             <a:avLst/>
@@ -7119,7 +7119,7 @@
               </a:lnSpc>
             </a:pPr>
             <a:r>
-              <a:rPr sz="1150" b="1" i="0">
+              <a:rPr sz="1200" b="1" i="0">
                 <a:solidFill>
                   <a:srgbClr val="162039"/>
                 </a:solidFill>
@@ -7140,8 +7140,8 @@
         </p:nvSpPr>
         <p:spPr>
           <a:xfrm>
-            <a:off x="2395728" y="4526280"/>
-            <a:ext cx="1828800" cy="530352"/>
+            <a:off x="2395728" y="4599431"/>
+            <a:ext cx="1828800" cy="548640"/>
           </a:xfrm>
           <a:prstGeom prst="rect">
             <a:avLst/>
@@ -7160,7 +7160,7 @@
               </a:lnSpc>
             </a:pPr>
             <a:r>
-              <a:rPr sz="1050" b="0" i="0">
+              <a:rPr sz="1200" b="0" i="0">
                 <a:solidFill>
                   <a:srgbClr val="1F2D45"/>
                 </a:solidFill>
@@ -7181,8 +7181,8 @@
         </p:nvSpPr>
         <p:spPr>
           <a:xfrm>
-            <a:off x="4389120" y="4526280"/>
-            <a:ext cx="1170431" cy="530352"/>
+            <a:off x="4389120" y="4599431"/>
+            <a:ext cx="1170431" cy="548640"/>
           </a:xfrm>
           <a:prstGeom prst="rect">
             <a:avLst/>
@@ -7201,7 +7201,7 @@
               </a:lnSpc>
             </a:pPr>
             <a:r>
-              <a:rPr sz="1100" b="1" i="0">
+              <a:rPr sz="1200" b="1" i="0">
                 <a:solidFill>
                   <a:srgbClr val="F43F5E"/>
                 </a:solidFill>
@@ -7222,8 +7222,8 @@
         </p:nvSpPr>
         <p:spPr>
           <a:xfrm>
-            <a:off x="5705856" y="4526280"/>
-            <a:ext cx="3776471" cy="530352"/>
+            <a:off x="5705856" y="4599431"/>
+            <a:ext cx="3776471" cy="548640"/>
           </a:xfrm>
           <a:prstGeom prst="rect">
             <a:avLst/>
@@ -7242,7 +7242,7 @@
               </a:lnSpc>
             </a:pPr>
             <a:r>
-              <a:rPr sz="1050" b="0" i="0">
+              <a:rPr sz="1200" b="0" i="0">
                 <a:solidFill>
                   <a:srgbClr val="1F2D45"/>
                 </a:solidFill>
@@ -7263,8 +7263,8 @@
         </p:nvSpPr>
         <p:spPr>
           <a:xfrm>
-            <a:off x="9665207" y="4526280"/>
-            <a:ext cx="1993392" cy="530352"/>
+            <a:off x="9665207" y="4599431"/>
+            <a:ext cx="1993392" cy="548640"/>
           </a:xfrm>
           <a:prstGeom prst="rect">
             <a:avLst/>
@@ -7283,7 +7283,7 @@
               </a:lnSpc>
             </a:pPr>
             <a:r>
-              <a:rPr sz="1050" b="1" i="0">
+              <a:rPr sz="1200" b="1" i="0">
                 <a:solidFill>
                   <a:srgbClr val="0E7490"/>
                 </a:solidFill>
@@ -7304,8 +7304,8 @@
         </p:nvSpPr>
         <p:spPr>
           <a:xfrm>
-            <a:off x="457200" y="5056632"/>
-            <a:ext cx="11274552" cy="530352"/>
+            <a:off x="457200" y="5148071"/>
+            <a:ext cx="11274552" cy="548640"/>
           </a:xfrm>
           <a:prstGeom prst="rect">
             <a:avLst/>
@@ -7350,8 +7350,8 @@
         </p:nvSpPr>
         <p:spPr>
           <a:xfrm>
-            <a:off x="566928" y="5056632"/>
-            <a:ext cx="1645920" cy="530352"/>
+            <a:off x="566928" y="5148071"/>
+            <a:ext cx="1645920" cy="548640"/>
           </a:xfrm>
           <a:prstGeom prst="rect">
             <a:avLst/>
@@ -7370,7 +7370,7 @@
               </a:lnSpc>
             </a:pPr>
             <a:r>
-              <a:rPr sz="1150" b="1" i="0">
+              <a:rPr sz="1200" b="1" i="0">
                 <a:solidFill>
                   <a:srgbClr val="162039"/>
                 </a:solidFill>
@@ -7391,8 +7391,8 @@
         </p:nvSpPr>
         <p:spPr>
           <a:xfrm>
-            <a:off x="2395728" y="5056632"/>
-            <a:ext cx="1828800" cy="530352"/>
+            <a:off x="2395728" y="5148071"/>
+            <a:ext cx="1828800" cy="548640"/>
           </a:xfrm>
           <a:prstGeom prst="rect">
             <a:avLst/>
@@ -7411,7 +7411,7 @@
               </a:lnSpc>
             </a:pPr>
             <a:r>
-              <a:rPr sz="1050" b="0" i="0">
+              <a:rPr sz="1200" b="0" i="0">
                 <a:solidFill>
                   <a:srgbClr val="1F2D45"/>
                 </a:solidFill>
@@ -7432,8 +7432,8 @@
         </p:nvSpPr>
         <p:spPr>
           <a:xfrm>
-            <a:off x="4389120" y="5056632"/>
-            <a:ext cx="1170431" cy="530352"/>
+            <a:off x="4389120" y="5148071"/>
+            <a:ext cx="1170431" cy="548640"/>
           </a:xfrm>
           <a:prstGeom prst="rect">
             <a:avLst/>
@@ -7452,7 +7452,7 @@
               </a:lnSpc>
             </a:pPr>
             <a:r>
-              <a:rPr sz="1100" b="1" i="0">
+              <a:rPr sz="1200" b="1" i="0">
                 <a:solidFill>
                   <a:srgbClr val="2A8F5F"/>
                 </a:solidFill>
@@ -7473,8 +7473,8 @@
         </p:nvSpPr>
         <p:spPr>
           <a:xfrm>
-            <a:off x="5705856" y="5056632"/>
-            <a:ext cx="3776471" cy="530352"/>
+            <a:off x="5705856" y="5148071"/>
+            <a:ext cx="3776471" cy="548640"/>
           </a:xfrm>
           <a:prstGeom prst="rect">
             <a:avLst/>
@@ -7493,7 +7493,7 @@
               </a:lnSpc>
             </a:pPr>
             <a:r>
-              <a:rPr sz="1050" b="0" i="0">
+              <a:rPr sz="1200" b="0" i="0">
                 <a:solidFill>
                   <a:srgbClr val="1F2D45"/>
                 </a:solidFill>
@@ -7514,8 +7514,8 @@
         </p:nvSpPr>
         <p:spPr>
           <a:xfrm>
-            <a:off x="9665207" y="5056632"/>
-            <a:ext cx="1993392" cy="530352"/>
+            <a:off x="9665207" y="5148071"/>
+            <a:ext cx="1993392" cy="548640"/>
           </a:xfrm>
           <a:prstGeom prst="rect">
             <a:avLst/>
@@ -7534,7 +7534,7 @@
               </a:lnSpc>
             </a:pPr>
             <a:r>
-              <a:rPr sz="1050" b="1" i="0">
+              <a:rPr sz="1200" b="1" i="0">
                 <a:solidFill>
                   <a:srgbClr val="0E7490"/>
                 </a:solidFill>
@@ -7555,8 +7555,8 @@
         </p:nvSpPr>
         <p:spPr>
           <a:xfrm>
-            <a:off x="457200" y="5586984"/>
-            <a:ext cx="11274552" cy="530352"/>
+            <a:off x="457200" y="5696711"/>
+            <a:ext cx="11274552" cy="548640"/>
           </a:xfrm>
           <a:prstGeom prst="rect">
             <a:avLst/>
@@ -7601,8 +7601,8 @@
         </p:nvSpPr>
         <p:spPr>
           <a:xfrm>
-            <a:off x="566928" y="5586984"/>
-            <a:ext cx="1645920" cy="530352"/>
+            <a:off x="566928" y="5696711"/>
+            <a:ext cx="1645920" cy="548640"/>
           </a:xfrm>
           <a:prstGeom prst="rect">
             <a:avLst/>
@@ -7621,7 +7621,7 @@
               </a:lnSpc>
             </a:pPr>
             <a:r>
-              <a:rPr sz="1150" b="1" i="0">
+              <a:rPr sz="1200" b="1" i="0">
                 <a:solidFill>
                   <a:srgbClr val="162039"/>
                 </a:solidFill>
@@ -7642,8 +7642,8 @@
         </p:nvSpPr>
         <p:spPr>
           <a:xfrm>
-            <a:off x="2395728" y="5586984"/>
-            <a:ext cx="1828800" cy="530352"/>
+            <a:off x="2395728" y="5696711"/>
+            <a:ext cx="1828800" cy="548640"/>
           </a:xfrm>
           <a:prstGeom prst="rect">
             <a:avLst/>
@@ -7662,7 +7662,7 @@
               </a:lnSpc>
             </a:pPr>
             <a:r>
-              <a:rPr sz="1050" b="0" i="0">
+              <a:rPr sz="1200" b="0" i="0">
                 <a:solidFill>
                   <a:srgbClr val="1F2D45"/>
                 </a:solidFill>
@@ -7683,8 +7683,8 @@
         </p:nvSpPr>
         <p:spPr>
           <a:xfrm>
-            <a:off x="4389120" y="5586984"/>
-            <a:ext cx="1170431" cy="530352"/>
+            <a:off x="4389120" y="5696711"/>
+            <a:ext cx="1170431" cy="548640"/>
           </a:xfrm>
           <a:prstGeom prst="rect">
             <a:avLst/>
@@ -7703,7 +7703,7 @@
               </a:lnSpc>
             </a:pPr>
             <a:r>
-              <a:rPr sz="1100" b="1" i="0">
+              <a:rPr sz="1200" b="1" i="0">
                 <a:solidFill>
                   <a:srgbClr val="5C6B8A"/>
                 </a:solidFill>
@@ -7724,8 +7724,8 @@
         </p:nvSpPr>
         <p:spPr>
           <a:xfrm>
-            <a:off x="5705856" y="5586984"/>
-            <a:ext cx="3776471" cy="530352"/>
+            <a:off x="5705856" y="5696711"/>
+            <a:ext cx="3776471" cy="548640"/>
           </a:xfrm>
           <a:prstGeom prst="rect">
             <a:avLst/>
@@ -7744,7 +7744,7 @@
               </a:lnSpc>
             </a:pPr>
             <a:r>
-              <a:rPr sz="1050" b="0" i="0">
+              <a:rPr sz="1200" b="0" i="0">
                 <a:solidFill>
                   <a:srgbClr val="1F2D45"/>
                 </a:solidFill>
@@ -7765,8 +7765,8 @@
         </p:nvSpPr>
         <p:spPr>
           <a:xfrm>
-            <a:off x="9665207" y="5586984"/>
-            <a:ext cx="1993392" cy="530352"/>
+            <a:off x="9665207" y="5696711"/>
+            <a:ext cx="1993392" cy="548640"/>
           </a:xfrm>
           <a:prstGeom prst="rect">
             <a:avLst/>
@@ -7785,7 +7785,7 @@
               </a:lnSpc>
             </a:pPr>
             <a:r>
-              <a:rPr sz="1050" b="1" i="0">
+              <a:rPr sz="1200" b="1" i="0">
                 <a:solidFill>
                   <a:srgbClr val="0E7490"/>
                 </a:solidFill>
@@ -7806,7 +7806,7 @@
         </p:nvSpPr>
         <p:spPr>
           <a:xfrm>
-            <a:off x="457200" y="6208776"/>
+            <a:off x="457200" y="6336791"/>
             <a:ext cx="11274552" cy="457200"/>
           </a:xfrm>
           <a:prstGeom prst="roundRect">
@@ -7854,7 +7854,7 @@
         </p:nvSpPr>
         <p:spPr>
           <a:xfrm>
-            <a:off x="640080" y="6208776"/>
+            <a:off x="640080" y="6336791"/>
             <a:ext cx="10908792" cy="457200"/>
           </a:xfrm>
           <a:prstGeom prst="rect">
@@ -7870,7 +7870,7 @@
           <a:p>
             <a:pPr algn="l"/>
             <a:r>
-              <a:rPr sz="1100" b="1" i="0">
+              <a:rPr sz="1200" b="1" i="0">
                 <a:solidFill>
                   <a:srgbClr val="8A5906"/>
                 </a:solidFill>
@@ -8033,7 +8033,7 @@
               <a:t>痛點</a:t>
             </a:r>
             <a:r>
-              <a:rPr sz="1100" b="1" i="0">
+              <a:rPr sz="1200" b="1" i="0">
                 <a:solidFill>
                   <a:srgbClr val="FFFFFF"/>
                 </a:solidFill>
@@ -8403,7 +8403,7 @@
           <a:p>
             <a:pPr algn="r"/>
             <a:r>
-              <a:rPr sz="1100" b="1" i="0">
+              <a:rPr sz="1200" b="1" i="0">
                 <a:solidFill>
                   <a:srgbClr val="F43F5E"/>
                 </a:solidFill>
@@ -9433,7 +9433,7 @@
               <a:t>解法</a:t>
             </a:r>
             <a:r>
-              <a:rPr sz="1100" b="1" i="0">
+              <a:rPr sz="1200" b="1" i="0">
                 <a:solidFill>
                   <a:srgbClr val="FFFFFF"/>
                 </a:solidFill>
@@ -9803,7 +9803,7 @@
           <a:p>
             <a:pPr algn="r"/>
             <a:r>
-              <a:rPr sz="1100" b="1" i="0">
+              <a:rPr sz="1200" b="1" i="0">
                 <a:solidFill>
                   <a:srgbClr val="06B6D4"/>
                 </a:solidFill>
@@ -10015,7 +10015,7 @@
               </a:lnSpc>
             </a:pPr>
             <a:r>
-              <a:rPr sz="1100" b="0" i="0">
+              <a:rPr sz="1200" b="0" i="0">
                 <a:solidFill>
                   <a:srgbClr val="C6D6F2"/>
                 </a:solidFill>
@@ -10190,7 +10190,7 @@
               </a:lnSpc>
             </a:pPr>
             <a:r>
-              <a:rPr sz="1100" b="0" i="0">
+              <a:rPr sz="1200" b="0" i="0">
                 <a:solidFill>
                   <a:srgbClr val="0B3A44"/>
                 </a:solidFill>
@@ -10365,7 +10365,7 @@
               </a:lnSpc>
             </a:pPr>
             <a:r>
-              <a:rPr sz="1100" b="0" i="0">
+              <a:rPr sz="1200" b="0" i="0">
                 <a:solidFill>
                   <a:srgbClr val="C6D6F2"/>
                 </a:solidFill>
@@ -10540,7 +10540,7 @@
               </a:lnSpc>
             </a:pPr>
             <a:r>
-              <a:rPr sz="1100" b="0" i="0">
+              <a:rPr sz="1200" b="0" i="0">
                 <a:solidFill>
                   <a:srgbClr val="0B3A44"/>
                 </a:solidFill>
@@ -10715,7 +10715,7 @@
               </a:lnSpc>
             </a:pPr>
             <a:r>
-              <a:rPr sz="1100" b="0" i="0">
+              <a:rPr sz="1200" b="0" i="0">
                 <a:solidFill>
                   <a:srgbClr val="C6D6F2"/>
                 </a:solidFill>
@@ -10862,7 +10862,7 @@
               <a:t>零學習成本　</a:t>
             </a:r>
             <a:r>
-              <a:rPr sz="1000" b="1" i="0">
+              <a:rPr sz="1200" b="1" i="0">
                 <a:solidFill>
                   <a:srgbClr val="06B6D4"/>
                 </a:solidFill>
@@ -11014,7 +11014,7 @@
           <a:p>
             <a:pPr algn="l"/>
             <a:r>
-              <a:rPr sz="1000" b="1" i="0">
+              <a:rPr sz="1200" b="1" i="0">
                 <a:solidFill>
                   <a:srgbClr val="F59E0B"/>
                 </a:solidFill>
@@ -11366,7 +11366,7 @@
               <a:t>演算法</a:t>
             </a:r>
             <a:r>
-              <a:rPr sz="1100" b="1" i="0">
+              <a:rPr sz="1200" b="1" i="0">
                 <a:solidFill>
                   <a:srgbClr val="FFFFFF"/>
                 </a:solidFill>
@@ -11736,7 +11736,7 @@
           <a:p>
             <a:pPr algn="r"/>
             <a:r>
-              <a:rPr sz="1100" b="1" i="0">
+              <a:rPr sz="1200" b="1" i="0">
                 <a:solidFill>
                   <a:srgbClr val="06B6D4"/>
                 </a:solidFill>
@@ -12008,7 +12008,7 @@
               <a:t>暴力解的代價　</a:t>
             </a:r>
             <a:r>
-              <a:rPr sz="1000" b="1" i="0">
+              <a:rPr sz="1200" b="1" i="0">
                 <a:solidFill>
                   <a:srgbClr val="F43F5E"/>
                 </a:solidFill>
@@ -12147,7 +12147,7 @@
               </a:lnSpc>
             </a:pPr>
             <a:r>
-              <a:rPr sz="1100" b="0" i="0">
+              <a:rPr sz="1200" b="0" i="0">
                 <a:solidFill>
                   <a:srgbClr val="5C6B8A"/>
                 </a:solidFill>
@@ -12237,7 +12237,7 @@
           <a:p>
             <a:pPr algn="l"/>
             <a:r>
-              <a:rPr sz="1000" b="1" i="0">
+              <a:rPr sz="1200" b="1" i="0">
                 <a:solidFill>
                   <a:srgbClr val="F59E0B"/>
                 </a:solidFill>
@@ -12318,7 +12318,7 @@
               </a:spcAft>
             </a:pPr>
             <a:r>
-              <a:rPr sz="1150" b="0" i="0">
+              <a:rPr sz="1200" b="0" i="0">
                 <a:solidFill>
                   <a:srgbClr val="C6D6F2"/>
                 </a:solidFill>
@@ -12347,7 +12347,7 @@
               <a:t>①  </a:t>
             </a:r>
             <a:r>
-              <a:rPr sz="1150" b="0" i="0">
+              <a:rPr sz="1200" b="0" i="0">
                 <a:solidFill>
                   <a:srgbClr val="C6D6F2"/>
                 </a:solidFill>
@@ -12376,7 +12376,7 @@
               <a:t>②  </a:t>
             </a:r>
             <a:r>
-              <a:rPr sz="1150" b="0" i="0">
+              <a:rPr sz="1200" b="0" i="0">
                 <a:solidFill>
                   <a:srgbClr val="C6D6F2"/>
                 </a:solidFill>
@@ -12405,7 +12405,7 @@
               <a:t>③  </a:t>
             </a:r>
             <a:r>
-              <a:rPr sz="1150" b="0" i="0">
+              <a:rPr sz="1200" b="0" i="0">
                 <a:solidFill>
                   <a:srgbClr val="C6D6F2"/>
                 </a:solidFill>
@@ -12423,7 +12423,7 @@
               </a:lnSpc>
             </a:pPr>
             <a:r>
-              <a:rPr sz="1000" b="0" i="0">
+              <a:rPr sz="1200" b="0" i="0">
                 <a:solidFill>
                   <a:srgbClr val="90A0C0"/>
                 </a:solidFill>
@@ -12431,7 +12431,7 @@
                 <a:ea typeface="PingFang TC"/>
                 <a:cs typeface="PingFang TC"/>
               </a:rPr>
-              <a:t>（同類思路：astrometry.net 星形 quad-hash、friends-of-friends 分群）</a:t>
+              <a:t>（同類思路：astrometry.net quad-hash、FoF 分群）</a:t>
             </a:r>
           </a:p>
         </p:txBody>
@@ -12565,7 +12565,7 @@
               </a:lnSpc>
             </a:pPr>
             <a:r>
-              <a:rPr sz="1150" b="1" i="0">
+              <a:rPr sz="1200" b="1" i="0">
                 <a:solidFill>
                   <a:srgbClr val="162039"/>
                 </a:solidFill>
@@ -12602,7 +12602,7 @@
           <a:p>
             <a:pPr algn="ctr"/>
             <a:r>
-              <a:rPr sz="950" b="0" i="0">
+              <a:rPr sz="1200" b="0" i="0">
                 <a:solidFill>
                   <a:srgbClr val="0B3A44"/>
                 </a:solidFill>
@@ -12740,7 +12740,7 @@
               </a:lnSpc>
             </a:pPr>
             <a:r>
-              <a:rPr sz="1150" b="1" i="0">
+              <a:rPr sz="1200" b="1" i="0">
                 <a:solidFill>
                   <a:srgbClr val="FFFFFF"/>
                 </a:solidFill>
@@ -12777,7 +12777,7 @@
           <a:p>
             <a:pPr algn="ctr"/>
             <a:r>
-              <a:rPr sz="950" b="0" i="0">
+              <a:rPr sz="1200" b="0" i="0">
                 <a:solidFill>
                   <a:srgbClr val="C6D6F2"/>
                 </a:solidFill>
@@ -12915,7 +12915,7 @@
               </a:lnSpc>
             </a:pPr>
             <a:r>
-              <a:rPr sz="1150" b="1" i="0">
+              <a:rPr sz="1200" b="1" i="0">
                 <a:solidFill>
                   <a:srgbClr val="162039"/>
                 </a:solidFill>
@@ -12952,7 +12952,7 @@
           <a:p>
             <a:pPr algn="ctr"/>
             <a:r>
-              <a:rPr sz="950" b="0" i="0">
+              <a:rPr sz="1200" b="0" i="0">
                 <a:solidFill>
                   <a:srgbClr val="0B3A44"/>
                 </a:solidFill>
@@ -13090,7 +13090,7 @@
               </a:lnSpc>
             </a:pPr>
             <a:r>
-              <a:rPr sz="1150" b="1" i="0">
+              <a:rPr sz="1200" b="1" i="0">
                 <a:solidFill>
                   <a:srgbClr val="FFFFFF"/>
                 </a:solidFill>
@@ -13127,7 +13127,7 @@
           <a:p>
             <a:pPr algn="ctr"/>
             <a:r>
-              <a:rPr sz="950" b="0" i="0">
+              <a:rPr sz="1200" b="0" i="0">
                 <a:solidFill>
                   <a:srgbClr val="C6D6F2"/>
                 </a:solidFill>
@@ -13265,7 +13265,7 @@
               </a:lnSpc>
             </a:pPr>
             <a:r>
-              <a:rPr sz="1150" b="1" i="0">
+              <a:rPr sz="1200" b="1" i="0">
                 <a:solidFill>
                   <a:srgbClr val="162039"/>
                 </a:solidFill>
@@ -13302,7 +13302,7 @@
           <a:p>
             <a:pPr algn="ctr"/>
             <a:r>
-              <a:rPr sz="950" b="0" i="0">
+              <a:rPr sz="1200" b="0" i="0">
                 <a:solidFill>
                   <a:srgbClr val="0B3A44"/>
                 </a:solidFill>
@@ -13595,7 +13595,7 @@
               <a:t>成效 ★</a:t>
             </a:r>
             <a:r>
-              <a:rPr sz="1100" b="1" i="0">
+              <a:rPr sz="1200" b="1" i="0">
                 <a:solidFill>
                   <a:srgbClr val="162039"/>
                 </a:solidFill>
@@ -13965,7 +13965,7 @@
           <a:p>
             <a:pPr algn="r"/>
             <a:r>
-              <a:rPr sz="1100" b="1" i="0">
+              <a:rPr sz="1200" b="1" i="0">
                 <a:solidFill>
                   <a:srgbClr val="F59E0B"/>
                 </a:solidFill>
@@ -14099,7 +14099,7 @@
           <a:p>
             <a:pPr algn="l"/>
             <a:r>
-              <a:rPr sz="1000" b="1" i="0">
+              <a:rPr sz="1200" b="1" i="0">
                 <a:solidFill>
                   <a:srgbClr val="22D3EE"/>
                 </a:solidFill>
@@ -14277,7 +14277,7 @@
           <a:p>
             <a:pPr algn="ctr"/>
             <a:r>
-              <a:rPr sz="1150" b="0" i="0">
+              <a:rPr sz="1200" b="0" i="0">
                 <a:solidFill>
                   <a:srgbClr val="D7F0F6"/>
                 </a:solidFill>
@@ -15360,7 +15360,7 @@
               </a:spcAft>
             </a:pPr>
             <a:r>
-              <a:rPr sz="1150" b="1" i="0">
+              <a:rPr sz="1200" b="1" i="0">
                 <a:solidFill>
                   <a:srgbClr val="22D3EE"/>
                 </a:solidFill>
@@ -15374,7 +15374,7 @@
           <a:p>
             <a:pPr algn="l"/>
             <a:r>
-              <a:rPr sz="1150" b="1" i="0">
+              <a:rPr sz="1200" b="1" i="0">
                 <a:solidFill>
                   <a:srgbClr val="C6D6F2"/>
                 </a:solidFill>
@@ -15537,7 +15537,7 @@
               <a:t>開發</a:t>
             </a:r>
             <a:r>
-              <a:rPr sz="1100" b="1" i="0">
+              <a:rPr sz="1200" b="1" i="0">
                 <a:solidFill>
                   <a:srgbClr val="FFFFFF"/>
                 </a:solidFill>
@@ -15907,7 +15907,7 @@
           <a:p>
             <a:pPr algn="r"/>
             <a:r>
-              <a:rPr sz="1100" b="1" i="0">
+              <a:rPr sz="1200" b="1" i="0">
                 <a:solidFill>
                   <a:srgbClr val="8B5CF6"/>
                 </a:solidFill>
@@ -16878,7 +16878,7 @@
           <a:p>
             <a:pPr algn="ctr"/>
             <a:r>
-              <a:rPr sz="1100" b="1" i="0">
+              <a:rPr sz="1200" b="1" i="0">
                 <a:solidFill>
                   <a:srgbClr val="FFFFFF"/>
                 </a:solidFill>
@@ -16961,7 +16961,7 @@
           <a:p>
             <a:pPr algn="ctr"/>
             <a:r>
-              <a:rPr sz="1100" b="1" i="0">
+              <a:rPr sz="1200" b="1" i="0">
                 <a:solidFill>
                   <a:srgbClr val="FFFFFF"/>
                 </a:solidFill>
@@ -17044,7 +17044,7 @@
           <a:p>
             <a:pPr algn="ctr"/>
             <a:r>
-              <a:rPr sz="1100" b="1" i="0">
+              <a:rPr sz="1200" b="1" i="0">
                 <a:solidFill>
                   <a:srgbClr val="162039"/>
                 </a:solidFill>
@@ -17140,7 +17140,7 @@
               </a:spcAft>
             </a:pPr>
             <a:r>
-              <a:rPr sz="1100" b="1" i="0">
+              <a:rPr sz="1200" b="1" i="0">
                 <a:solidFill>
                   <a:srgbClr val="0E7490"/>
                 </a:solidFill>
@@ -17151,7 +17151,7 @@
               <a:t>Skills｜自建技能生態　</a:t>
             </a:r>
             <a:r>
-              <a:rPr sz="1000" b="0" i="0">
+              <a:rPr sz="1200" b="0" i="0">
                 <a:solidFill>
                   <a:srgbClr val="1F2D45"/>
                 </a:solidFill>
@@ -17159,13 +17159,13 @@
                 <a:ea typeface="PingFang TC"/>
                 <a:cs typeface="PingFang TC"/>
               </a:rPr>
-              <a:t>規格流 spectra-* ×12（propose→apply→archive→verify…）· 測試 tdd · 審查 grill-me / grill-with-docs / diagnose / triage</a:t>
+              <a:t>規格流 spectra-* ×12 · 測試 tdd · 審查 grill-me / diagnose / triage</a:t>
             </a:r>
           </a:p>
           <a:p>
             <a:pPr algn="l"/>
             <a:r>
-              <a:rPr sz="1000" b="0" i="0">
+              <a:rPr sz="1200" b="0" i="0">
                 <a:solidFill>
                   <a:srgbClr val="5C6B8A"/>
                 </a:solidFill>
@@ -17173,7 +17173,7 @@
                 <a:ea typeface="PingFang TC"/>
                 <a:cs typeface="PingFang TC"/>
               </a:rPr>
-              <a:t>規劃 to-prd / to-issues · 領域 add-rule · 雛型 prototype · 架構 improve-codebase-architecture · zoom-out · write-a-skill · caveman</a:t>
+              <a:t>規劃 to-prd / to-issues · 領域 add-rule · 雛型 prototype · 架構 improve-codebase-architecture 等</a:t>
             </a:r>
           </a:p>
         </p:txBody>
@@ -17340,7 +17340,7 @@
           <a:p>
             <a:pPr algn="ctr"/>
             <a:r>
-              <a:rPr sz="1050" b="1" i="0">
+              <a:rPr sz="1200" b="1" i="0">
                 <a:solidFill>
                   <a:srgbClr val="FFFFFF"/>
                 </a:solidFill>
@@ -17377,7 +17377,7 @@
           <a:p>
             <a:pPr algn="l"/>
             <a:r>
-              <a:rPr sz="1100" b="0" i="0">
+              <a:rPr sz="1200" b="0" i="0">
                 <a:solidFill>
                   <a:srgbClr val="1F2D45"/>
                 </a:solidFill>
@@ -17460,7 +17460,7 @@
           <a:p>
             <a:pPr algn="ctr"/>
             <a:r>
-              <a:rPr sz="1050" b="1" i="0">
+              <a:rPr sz="1200" b="1" i="0">
                 <a:solidFill>
                   <a:srgbClr val="FFFFFF"/>
                 </a:solidFill>
@@ -17497,7 +17497,7 @@
           <a:p>
             <a:pPr algn="l"/>
             <a:r>
-              <a:rPr sz="1100" b="0" i="0">
+              <a:rPr sz="1200" b="0" i="0">
                 <a:solidFill>
                   <a:srgbClr val="1F2D45"/>
                 </a:solidFill>
@@ -17580,7 +17580,7 @@
           <a:p>
             <a:pPr algn="ctr"/>
             <a:r>
-              <a:rPr sz="1050" b="1" i="0">
+              <a:rPr sz="1200" b="1" i="0">
                 <a:solidFill>
                   <a:srgbClr val="FFFFFF"/>
                 </a:solidFill>
@@ -17617,7 +17617,7 @@
           <a:p>
             <a:pPr algn="l"/>
             <a:r>
-              <a:rPr sz="1100" b="0" i="0">
+              <a:rPr sz="1200" b="0" i="0">
                 <a:solidFill>
                   <a:srgbClr val="1F2D45"/>
                 </a:solidFill>
@@ -17700,7 +17700,7 @@
           <a:p>
             <a:pPr algn="ctr"/>
             <a:r>
-              <a:rPr sz="1050" b="1" i="0">
+              <a:rPr sz="1200" b="1" i="0">
                 <a:solidFill>
                   <a:srgbClr val="FFFFFF"/>
                 </a:solidFill>
@@ -17737,7 +17737,7 @@
           <a:p>
             <a:pPr algn="l"/>
             <a:r>
-              <a:rPr sz="1100" b="0" i="0">
+              <a:rPr sz="1200" b="0" i="0">
                 <a:solidFill>
                   <a:srgbClr val="1F2D45"/>
                 </a:solidFill>
@@ -17774,7 +17774,7 @@
           <a:p>
             <a:pPr algn="ctr"/>
             <a:r>
-              <a:rPr sz="1150" b="1" i="0">
+              <a:rPr sz="1200" b="1" i="0">
                 <a:solidFill>
                   <a:srgbClr val="0E7490"/>
                 </a:solidFill>
@@ -17937,7 +17937,7 @@
               <a:t>品質</a:t>
             </a:r>
             <a:r>
-              <a:rPr sz="1100" b="1" i="0">
+              <a:rPr sz="1200" b="1" i="0">
                 <a:solidFill>
                   <a:srgbClr val="FFFFFF"/>
                 </a:solidFill>
@@ -18307,7 +18307,7 @@
           <a:p>
             <a:pPr algn="r"/>
             <a:r>
-              <a:rPr sz="1100" b="1" i="0">
+              <a:rPr sz="1200" b="1" i="0">
                 <a:solidFill>
                   <a:srgbClr val="0E7490"/>
                 </a:solidFill>
@@ -19057,7 +19057,7 @@
           <a:p>
             <a:pPr algn="l"/>
             <a:r>
-              <a:rPr sz="1000" b="1" i="0">
+              <a:rPr sz="1200" b="1" i="0">
                 <a:solidFill>
                   <a:srgbClr val="22D3EE"/>
                 </a:solidFill>
@@ -19360,7 +19360,7 @@
               <a:t>擴展</a:t>
             </a:r>
             <a:r>
-              <a:rPr sz="1100" b="1" i="0">
+              <a:rPr sz="1200" b="1" i="0">
                 <a:solidFill>
                   <a:srgbClr val="FFFFFF"/>
                 </a:solidFill>
@@ -19730,7 +19730,7 @@
           <a:p>
             <a:pPr algn="r"/>
             <a:r>
-              <a:rPr sz="1100" b="1" i="0">
+              <a:rPr sz="1200" b="1" i="0">
                 <a:solidFill>
                   <a:srgbClr val="2A8F5F"/>
                 </a:solidFill>
@@ -20406,7 +20406,7 @@
           <a:p>
             <a:pPr algn="ctr"/>
             <a:r>
-              <a:rPr sz="1150" b="0" i="0">
+              <a:rPr sz="1200" b="0" i="0">
                 <a:solidFill>
                   <a:srgbClr val="90A0C0"/>
                 </a:solidFill>
@@ -20585,7 +20585,7 @@
           <a:p>
             <a:pPr algn="ctr"/>
             <a:r>
-              <a:rPr sz="1100" b="1" i="0">
+              <a:rPr sz="1200" b="1" i="0">
                 <a:solidFill>
                   <a:srgbClr val="FFFFFF"/>
                 </a:solidFill>
@@ -20764,7 +20764,7 @@
           <a:p>
             <a:pPr algn="ctr"/>
             <a:r>
-              <a:rPr sz="1100" b="1" i="0">
+              <a:rPr sz="1200" b="1" i="0">
                 <a:solidFill>
                   <a:srgbClr val="FFFFFF"/>
                 </a:solidFill>
@@ -20943,7 +20943,7 @@
           <a:p>
             <a:pPr algn="ctr"/>
             <a:r>
-              <a:rPr sz="1100" b="1" i="0">
+              <a:rPr sz="1200" b="1" i="0">
                 <a:solidFill>
                   <a:srgbClr val="FFFFFF"/>
                 </a:solidFill>
@@ -21122,7 +21122,7 @@
           <a:p>
             <a:pPr algn="ctr"/>
             <a:r>
-              <a:rPr sz="1100" b="1" i="0">
+              <a:rPr sz="1200" b="1" i="0">
                 <a:solidFill>
                   <a:srgbClr val="FFFFFF"/>
                 </a:solidFill>
@@ -21301,7 +21301,7 @@
           <a:p>
             <a:pPr algn="ctr"/>
             <a:r>
-              <a:rPr sz="1100" b="1" i="0">
+              <a:rPr sz="1200" b="1" i="0">
                 <a:solidFill>
                   <a:srgbClr val="FFFFFF"/>
                 </a:solidFill>
@@ -21924,7 +21924,7 @@
           <a:p>
             <a:pPr algn="ctr"/>
             <a:r>
-              <a:rPr sz="1050" b="0" i="0">
+              <a:rPr sz="1200" b="0" i="0">
                 <a:solidFill>
                   <a:srgbClr val="90A0C0"/>
                 </a:solidFill>
@@ -22051,7 +22051,7 @@
           <a:p>
             <a:pPr algn="ctr"/>
             <a:r>
-              <a:rPr sz="1050" b="0" i="0">
+              <a:rPr sz="1200" b="0" i="0">
                 <a:solidFill>
                   <a:srgbClr val="90A0C0"/>
                 </a:solidFill>
@@ -22178,7 +22178,7 @@
           <a:p>
             <a:pPr algn="ctr"/>
             <a:r>
-              <a:rPr sz="1050" b="0" i="0">
+              <a:rPr sz="1200" b="0" i="0">
                 <a:solidFill>
                   <a:srgbClr val="90A0C0"/>
                 </a:solidFill>
@@ -22215,7 +22215,7 @@
           <a:p>
             <a:pPr algn="r"/>
             <a:r>
-              <a:rPr sz="1100" b="1" i="0">
+              <a:rPr sz="1200" b="1" i="0">
                 <a:solidFill>
                   <a:srgbClr val="22D3EE"/>
                 </a:solidFill>

</xml_diff>

<commit_message>
deck: pptx notes 時間帶對齊 6:00 演講本體(Q&A 另計)
build_deck.py 九頁 ⏱ 時間帶與 Q&A/BACKUP note 重排(P1 0:00–0:18 …
P9 5:38–6:00、Q&A 6:00 後另計),docstring 改 6 分鐘簡報;重建 pptx。

Co-Authored-By: Claude Opus 4.8 (1M context) <noreply@anthropic.com>
</commit_message>
<xml_diff>
--- a/competition/尋形Conform_競賽簡報.pptx
+++ b/competition/尋形Conform_競賽簡報.pptx
@@ -512,7 +512,7 @@
           <a:lstStyle/>
           <a:p>
             <a:r>
-              <a:t>⏱ 0:00–0:20（20 秒）</a:t>
+              <a:t>⏱ 0:00–0:18（18 秒）</a:t>
             </a:r>
           </a:p>
           <a:p>
@@ -592,7 +592,7 @@
           <a:lstStyle/>
           <a:p>
             <a:r>
-              <a:t>⏱ 7:00–10:00（3 分鐘問答）</a:t>
+              <a:t>⏱ 6:00 後 · Q&amp;A（另計，約 3 分鐘）</a:t>
             </a:r>
           </a:p>
           <a:p>
@@ -677,7 +677,7 @@
           <a:lstStyle/>
           <a:p>
             <a:r>
-              <a:t>BACKUP 頁——不在 7 分鐘主線內，只在 Q&amp;A 被深問『哪些採用哪些否決、怎麼討論』時切過來逐列講。</a:t>
+              <a:t>BACKUP 頁——不在 6 分鐘主線內，只在 Q&amp;A 被深問『哪些採用哪些否決、怎麼討論』時切過來逐列講。</a:t>
             </a:r>
           </a:p>
           <a:p>
@@ -762,7 +762,7 @@
           <a:lstStyle/>
           <a:p>
             <a:r>
-              <a:t>⏱ 0:20–1:05（45 秒）</a:t>
+              <a:t>⏱ 0:18–0:58（40 秒）</a:t>
             </a:r>
           </a:p>
           <a:p>
@@ -837,7 +837,7 @@
           <a:lstStyle/>
           <a:p>
             <a:r>
-              <a:t>⏱ 1:05–1:50（45 秒）</a:t>
+              <a:t>⏱ 0:58–1:38（40 秒）</a:t>
             </a:r>
           </a:p>
           <a:p>
@@ -922,7 +922,7 @@
           <a:lstStyle/>
           <a:p>
             <a:r>
-              <a:t>⏱ 1:50–2:50（60 秒）——演算法 + 複雜度 + 天文學靈感頁。</a:t>
+              <a:t>⏱ 1:38–2:30（52 秒）——演算法 + 複雜度 + 天文學靈感頁。</a:t>
             </a:r>
           </a:p>
           <a:p>
@@ -1032,7 +1032,7 @@
           <a:lstStyle/>
           <a:p>
             <a:r>
-              <a:t>⏱ 2:50–4:05（75 秒）——★ 最高權重(40%)的核心頁，講最久。</a:t>
+              <a:t>⏱ 2:30–3:38（68 秒）——★ 最高權重(40%)的核心頁，講最久。</a:t>
             </a:r>
           </a:p>
           <a:p>
@@ -1122,7 +1122,7 @@
           <a:lstStyle/>
           <a:p>
             <a:r>
-              <a:t>⏱ 4:05–4:40（35 秒）——核心理念頁，給後半場定調。</a:t>
+              <a:t>⏱ 3:38–4:08（30 秒）——核心理念頁，給後半場定調。</a:t>
             </a:r>
           </a:p>
           <a:p>
@@ -1207,7 +1207,7 @@
           <a:lstStyle/>
           <a:p>
             <a:r>
-              <a:t>⏱ 4:40–5:35（55 秒）</a:t>
+              <a:t>⏱ 4:08–4:55（47 秒）</a:t>
             </a:r>
           </a:p>
           <a:p>
@@ -1359,7 +1359,7 @@
           <a:lstStyle/>
           <a:p>
             <a:r>
-              <a:t>⏱ 5:35–6:25（50 秒）——把 25%+25% 兩個品質軸(程式品質 + 開發流程)合在這頁高密度交代。</a:t>
+              <a:t>⏱ 4:55–5:38（43 秒）——把 25%+25% 兩個品質軸(程式品質 + 開發流程)合在這頁高密度交代。</a:t>
             </a:r>
           </a:p>
           <a:p>
@@ -1454,7 +1454,7 @@
           <a:lstStyle/>
           <a:p>
             <a:r>
-              <a:t>⏱ 6:25–7:00（35 秒）——創新 10% 核心 + 應用廣度收尾。</a:t>
+              <a:t>⏱ 5:38–6:00（22 秒）——創新 10% 核心 + 應用廣度收尾。</a:t>
             </a:r>
           </a:p>
           <a:p>

</xml_diff>